<commit_message>
[deliverable-renderer] BCS+BT-03 final: 0 placeholders remaining (1 contact intentional), 14 EVs cited, 100% docx coverage
</commit_message>
<xml_diff>
--- a/outputs/PoV_Review_PerSense.pptx
+++ b/outputs/PoV_Review_PerSense.pptx
@@ -4228,7 +4228,7 @@
                 <a:defRPr/>
               </a:pPr>
               <a:r>
-                <a:rPr kumimoji="0" lang="pt-PT" sz="1400" b="0" i="0" u="none" strike="noStrike" kern="1200" cap="none" spc="-150" normalizeH="0" baseline="0" noProof="0" dirty="0">
+                <a:rPr kumimoji="0" lang="pt-PT" sz="1100" b="0" i="0" u="none" strike="noStrike" kern="1200" cap="none" spc="-150" normalizeH="0" baseline="0" noProof="0" dirty="0">
                   <a:ln>
                     <a:noFill/>
                   </a:ln>
@@ -4242,7 +4242,7 @@
                   <a:ea typeface="+mn-ea"/>
                   <a:cs typeface="+mn-cs"/>
                 </a:rPr>
-                <a:t>Estudantes universitários portugueses (18–25) com sintomas de ansiedade/depressão ligeiros a moderados que recorrem ao SNS ou linhas digitais: 75% reportam ansiedade e 61,2% depressão [EV-005], mas o SNS tem só ~1.100 psicólogos para 10,3M habitantes [EV-012] e a espera supera 300 dias em Santarém [EV-013]. O canal digital aumenta contactos mas não resolve: triagem fragmentada e sem acompanhamento entre sessões deixa sintomas escalar até à urgência.</a:t>
+                <a:t>Para sobreviventes de cancro da mama (BCS) nos primeiros 24 meses pós-tratamento, em follow-up senologia/oncologia hospitalar (PT), o problema é a recaída emocional entre consultas: 30–40% desenvolvem ansiedade/depressão clínica [EV-019] e &lt;20% recebem apoio formal [EV-016]. Picos fora da consulta ficam invisíveis (medir PHQ-9/GAD-7 e dias até contacto). Status quo falha por triagem episódica → sintomas escalam sem deteção. Pergunta: que sinal passivo as BCS aceitam sem sobrecarregar a equipa?</a:t>
               </a:r>
             </a:p>
           </p:txBody>
@@ -4769,7 +4769,7 @@
                   <a:ea typeface="+mn-ea"/>
                   <a:cs typeface="+mn-cs"/>
                 </a:rPr>
-                <a:t>Check-ins adaptativos no primeiro contacto reduzem abandono de 52,7% para ≤30% em 10 semanas.</a:t>
+                <a:t>Monitorização adaptativa entre consultas reduz PHQ-9/GAD-7 em BCS pós-tratamento (semanas 0-12).</a:t>
               </a:r>
             </a:p>
           </p:txBody>
@@ -5003,7 +5003,7 @@
                 <a:defRPr/>
               </a:pPr>
               <a:r>
-                <a:rPr kumimoji="0" lang="pt-PT" sz="1400" b="0" i="0" u="none" strike="noStrike" kern="1200" cap="none" spc="-150" normalizeH="0" baseline="0" noProof="0" dirty="0">
+                <a:rPr kumimoji="0" lang="pt-PT" sz="900" b="0" i="0" u="none" strike="noStrike" kern="1200" cap="none" spc="-150" normalizeH="0" baseline="0" noProof="0" dirty="0">
                   <a:ln>
                     <a:noFill/>
                   </a:ln>
@@ -5017,7 +5017,7 @@
                   <a:ea typeface="+mn-ea"/>
                   <a:cs typeface="+mn-cs"/>
                 </a:rPr>
-                <a:t>Taxa de retenção entre primeiro contacto digital e segunda interacção clínica útil (4 semanas) — baseline 52,7% de falha de triagem/abandono no fluxo análogo iNNOVSensing — i.e., retenção ~47% [EV-042]; target Retenção ≥70% às 4 semanas (equivalente a redução de abandono de 52,7% para ≤30%) sustentada até semana 10</a:t>
+                <a:t>(principal) Redução média PHQ-9 ≥3 pontos e GAD-7 ≥2 pontos às 12 semanas em BCS consentidas, com replicação da AUC 0.78 [EV-043, internal_only] na deteção de recaída entre consultas em cohort PT independente.</a:t>
               </a:r>
             </a:p>
           </p:txBody>
@@ -5314,7 +5314,7 @@
               <a:defRPr/>
             </a:pPr>
             <a:r>
-              <a:rPr kumimoji="0" lang="pt-PT" sz="1400" b="0" i="0" u="none" strike="noStrike" kern="1200" cap="none" spc="-150" normalizeH="0" baseline="0" noProof="0" dirty="0">
+              <a:rPr kumimoji="0" lang="pt-PT" sz="900" b="0" i="0" u="none" strike="noStrike" kern="1200" cap="none" spc="-150" normalizeH="0" baseline="0" noProof="0" dirty="0">
                 <a:ln>
                   <a:noFill/>
                 </a:ln>
@@ -5328,7 +5328,7 @@
                 <a:ea typeface="+mn-ea"/>
                 <a:cs typeface="+mn-cs"/>
               </a:rPr>
-              <a:t>Compliance de check-ins EMA/JITAI por participante por semana — ≥45% de respostas a prompts adaptativos durante 8 semanas (≥3 interacções úteis/semana por utilizador activo)</a:t>
+              <a:t>(suporte 1) Precisão/recall da deteção de deterioração entre consultas: precisão ≥0.70, recall ≥0.65 contra avaliação clínica de referência (PHQ-9/GAD-7 ≥10 confirmatório), com volume de alertas bounded ≤2/clínico/semana.</a:t>
             </a:r>
           </a:p>
         </p:txBody>
@@ -5379,7 +5379,7 @@
               <a:defRPr/>
             </a:pPr>
             <a:r>
-              <a:rPr kumimoji="0" lang="pt-PT" sz="1400" b="0" i="0" u="none" strike="noStrike" kern="1200" cap="none" spc="-150" normalizeH="0" baseline="0" noProof="0" dirty="0">
+              <a:rPr kumimoji="0" lang="pt-PT" sz="900" b="0" i="0" u="none" strike="noStrike" kern="1200" cap="none" spc="-150" normalizeH="0" baseline="0" noProof="0" dirty="0">
                 <a:ln>
                   <a:noFill/>
                 </a:ln>
@@ -5393,7 +5393,7 @@
                 <a:ea typeface="+mn-ea"/>
                 <a:cs typeface="+mn-cs"/>
               </a:rPr>
-              <a:t>Redução sintomática auto-reportada (GAD-7 / PHQ-9) entre baseline e semana 8 — Redução média ≥20% no GAD-7 e/ou PHQ-9 na coorte aderente; ≥50% dos participantes com melhoria clinicamente relevante (≥4 pontos)</a:t>
+              <a:t>(suporte 2) ≥2 unidades de senologia privada PT (CUF / Lusíadas / Luz Saúde) assinam LOI ou piloto pago a ≥€200/clínico/mês até semana 12 [EV-047], com DPIA GDPR co-assinado por DPO hospitalar [EV-062].</a:t>
             </a:r>
           </a:p>
         </p:txBody>
@@ -5561,7 +5561,7 @@
                   <a:ea typeface="+mn-ea"/>
                   <a:cs typeface="+mn-cs"/>
                 </a:rPr>
-                <a:t>EV-005 — Estudantes universitários PT (18–25) com sintomas de ansiedade — 75% ansiedade; 61,2% depressão (N=3.399) (Amaro et al., 2024 — estudo nacional 3.399 estudantes)</a:t>
+                <a:t>Sobreviventes cancro mama (BCS) — PT e UE · ~36K (PT); ~750K (UE) · Relatório Saúde Mental Digital (GLOBOCAN 2022) [EV-020]</a:t>
               </a:r>
             </a:p>
             <a:p>
@@ -5597,7 +5597,7 @@
                   <a:ea typeface="+mn-ea"/>
                   <a:cs typeface="+mn-cs"/>
                 </a:rPr>
-                <a:t>EV-012 — Capacidade SNS: psicólogos por habitante (vs objectivo legal) — ~1.100 psicólogos / 10,3M (rácio ~1:9.400; meta 1:5.000) (SNS / Resolução AR n.º 158/2021)</a:t>
+                <a:t>BCS com ansiedade/depressão clínica · 30–40% · Relatório Saúde Mental Digital — Epidemiologia [EV-019]</a:t>
               </a:r>
             </a:p>
             <a:p>
@@ -5633,7 +5633,7 @@
                   <a:ea typeface="+mn-ea"/>
                   <a:cs typeface="+mn-cs"/>
                 </a:rPr>
-                <a:t>EV-013 — Tempo de espera para 1.ª consulta de psicologia no SNS (2024) — &gt;300 dias (Santarém); 254 (Aveiro); 240 (Chaves) (Dados SNS, 2024)</a:t>
+                <a:t>BCS que recebem apoio psicológico formal · &lt;20% · Relatório Saúde Mental Digital — Treatment gap [EV-016]</a:t>
               </a:r>
             </a:p>
             <a:p>
@@ -5669,7 +5669,7 @@
                   <a:ea typeface="+mn-ea"/>
                   <a:cs typeface="+mn-cs"/>
                 </a:rPr>
-                <a:t>EV-042 — Abandono no fluxo digital actual (baseline iNNOVSensing) — 52,7% falha de triagem (retenção ~47%) (Relatório Estratégico PerSense / iNNOVSensing)</a:t>
+                <a:t>mHealth: redução de ansiedade / depressão · SMD -0,68 / -0,49 (139 RCTs, N=19.233) · Meta-análise mHealth, 2025 [EV-023]</a:t>
               </a:r>
             </a:p>
             <a:p>
@@ -5705,7 +5705,7 @@
                   <a:ea typeface="+mn-ea"/>
                   <a:cs typeface="+mn-cs"/>
                 </a:rPr>
-                <a:t>EV-023 — Precedente clínico: mHealth reduz ansiedade/depressão — SMD -0,68 ansiedade; -0,49 depressão (139 RCTs, N=19.233) (Meta-análise mHealth, 2025)</a:t>
+                <a:t>Reembolso DiGA por paciente/ano (DE, GKV) · €200–600 (cobertura 73M segurados) · BfArM — Modelo DiGA / GKV [EV-060]</a:t>
               </a:r>
             </a:p>
           </p:txBody>
@@ -6200,7 +6200,7 @@
                 <a:defRPr/>
               </a:pPr>
               <a:r>
-                <a:rPr kumimoji="0" lang="pt-PT" sz="1000" b="0" i="0" u="none" strike="noStrike" kern="1200" cap="none" spc="-150" normalizeH="0" baseline="0" noProof="0" dirty="0">
+                <a:rPr kumimoji="0" lang="pt-PT" sz="900" b="0" i="0" u="none" strike="noStrike" kern="1200" cap="none" spc="-150" normalizeH="0" baseline="0" noProof="0" dirty="0">
                   <a:ln>
                     <a:noFill/>
                   </a:ln>
@@ -6214,367 +6214,7 @@
                   <a:ea typeface="+mn-ea"/>
                   <a:cs typeface="+mn-cs"/>
                 </a:rPr>
-                <a:t>Hipótese operacional:</a:t>
-              </a:r>
-            </a:p>
-            <a:p>
-              <a:pPr marL="0" marR="0" lvl="0" indent="0" algn="l" defTabSz="914400" rtl="0" eaLnBrk="1" fontAlgn="auto" latinLnBrk="0" hangingPunct="1">
-                <a:lnSpc>
-                  <a:spcPts val="3060"/>
-                </a:lnSpc>
-                <a:spcBef>
-                  <a:spcPts val="0"/>
-                </a:spcBef>
-                <a:spcAft>
-                  <a:spcPts val="0"/>
-                </a:spcAft>
-                <a:buClrTx/>
-                <a:buSzTx/>
-                <a:buFontTx/>
-                <a:buNone/>
-                <a:tabLst/>
-                <a:defRPr/>
-              </a:pPr>
-              <a:r>
-                <a:rPr kumimoji="0" lang="pt-PT" sz="1000" b="0" i="0" u="none" strike="noStrike" kern="1200" cap="none" spc="-150" normalizeH="0" baseline="0" noProof="0" dirty="0">
-                  <a:ln>
-                    <a:noFill/>
-                  </a:ln>
-                  <a:solidFill>
-                    <a:srgbClr val="342662"/>
-                  </a:solidFill>
-                  <a:effectLst/>
-                  <a:uLnTx/>
-                  <a:uFillTx/>
-                  <a:latin typeface="Aptos" panose="02110004020202020204"/>
-                  <a:ea typeface="+mn-ea"/>
-                  <a:cs typeface="+mn-cs"/>
-                </a:rPr>
-                <a:t>If estudantes universitários portugueses (18–25) em primeiro contacto via canal digital SNS / linha municipal forem onboardados num fluxo de check-ins adaptativos (EMA + JITAI) entregue via mindLAMP (Stack A) com triagem ligeira mediada por psicólogo do SASU/serviço de aconselhamento, então a retenção entre 1.º contacto e 2.ª interacção clínica útil às 4 semanas será ≥70% (vs. baseline 47% derivado de EV-042), com compliance EMA ≥45% (EV-040) e redução média GAD-7/PHQ-9 ≥20% à semana 8 (EV-023, EV-031).</a:t>
-              </a:r>
-            </a:p>
-            <a:p>
-              <a:pPr marL="0" marR="0" lvl="0" indent="0" algn="l" defTabSz="914400" rtl="0" eaLnBrk="1" fontAlgn="auto" latinLnBrk="0" hangingPunct="1">
-                <a:lnSpc>
-                  <a:spcPts val="3060"/>
-                </a:lnSpc>
-                <a:spcBef>
-                  <a:spcPts val="0"/>
-                </a:spcBef>
-                <a:spcAft>
-                  <a:spcPts val="0"/>
-                </a:spcAft>
-                <a:buClrTx/>
-                <a:buSzTx/>
-                <a:buFontTx/>
-                <a:buNone/>
-                <a:tabLst/>
-                <a:defRPr/>
-              </a:pPr>
-              <a:r>
-                <a:rPr kumimoji="0" lang="pt-PT" sz="1000" b="0" i="0" u="none" strike="noStrike" kern="1200" cap="none" spc="-150" normalizeH="0" baseline="0" noProof="0" dirty="0">
-                  <a:ln>
-                    <a:noFill/>
-                  </a:ln>
-                  <a:solidFill>
-                    <a:srgbClr val="342662"/>
-                  </a:solidFill>
-                  <a:effectLst/>
-                  <a:uLnTx/>
-                  <a:uFillTx/>
-                  <a:latin typeface="Aptos" panose="02110004020202020204"/>
-                  <a:ea typeface="+mn-ea"/>
-                  <a:cs typeface="+mn-cs"/>
-                </a:rPr>
-                <a:t/>
-              </a:r>
-            </a:p>
-            <a:p>
-              <a:pPr marL="0" marR="0" lvl="0" indent="0" algn="l" defTabSz="914400" rtl="0" eaLnBrk="1" fontAlgn="auto" latinLnBrk="0" hangingPunct="1">
-                <a:lnSpc>
-                  <a:spcPts val="3060"/>
-                </a:lnSpc>
-                <a:spcBef>
-                  <a:spcPts val="0"/>
-                </a:spcBef>
-                <a:spcAft>
-                  <a:spcPts val="0"/>
-                </a:spcAft>
-                <a:buClrTx/>
-                <a:buSzTx/>
-                <a:buFontTx/>
-                <a:buNone/>
-                <a:tabLst/>
-                <a:defRPr/>
-              </a:pPr>
-              <a:r>
-                <a:rPr kumimoji="0" lang="pt-PT" sz="1000" b="0" i="0" u="none" strike="noStrike" kern="1200" cap="none" spc="-150" normalizeH="0" baseline="0" noProof="0" dirty="0">
-                  <a:ln>
-                    <a:noFill/>
-                  </a:ln>
-                  <a:solidFill>
-                    <a:srgbClr val="342662"/>
-                  </a:solidFill>
-                  <a:effectLst/>
-                  <a:uLnTx/>
-                  <a:uFillTx/>
-                  <a:latin typeface="Aptos" panose="02110004020202020204"/>
-                  <a:ea typeface="+mn-ea"/>
-                  <a:cs typeface="+mn-cs"/>
-                </a:rPr>
-                <a:t>Coorte: 40 estudantes 18–25, 1.º contacto digital SASU/linha municipal.</a:t>
-              </a:r>
-            </a:p>
-            <a:p>
-              <a:pPr marL="0" marR="0" lvl="0" indent="0" algn="l" defTabSz="914400" rtl="0" eaLnBrk="1" fontAlgn="auto" latinLnBrk="0" hangingPunct="1">
-                <a:lnSpc>
-                  <a:spcPts val="3060"/>
-                </a:lnSpc>
-                <a:spcBef>
-                  <a:spcPts val="0"/>
-                </a:spcBef>
-                <a:spcAft>
-                  <a:spcPts val="0"/>
-                </a:spcAft>
-                <a:buClrTx/>
-                <a:buSzTx/>
-                <a:buFontTx/>
-                <a:buNone/>
-                <a:tabLst/>
-                <a:defRPr/>
-              </a:pPr>
-              <a:r>
-                <a:rPr kumimoji="0" lang="pt-PT" sz="1000" b="0" i="0" u="none" strike="noStrike" kern="1200" cap="none" spc="-150" normalizeH="0" baseline="0" noProof="0" dirty="0">
-                  <a:ln>
-                    <a:noFill/>
-                  </a:ln>
-                  <a:solidFill>
-                    <a:srgbClr val="342662"/>
-                  </a:solidFill>
-                  <a:effectLst/>
-                  <a:uLnTx/>
-                  <a:uFillTx/>
-                  <a:latin typeface="Aptos" panose="02110004020202020204"/>
-                  <a:ea typeface="+mn-ea"/>
-                  <a:cs typeface="+mn-cs"/>
-                </a:rPr>
-                <a:t>Stack: mindLAMP self-hosted Hetzner DE (GDPR); EMA + JITAI rule-based; sem ML; sem wearables.</a:t>
-              </a:r>
-            </a:p>
-            <a:p>
-              <a:pPr marL="0" marR="0" lvl="0" indent="0" algn="l" defTabSz="914400" rtl="0" eaLnBrk="1" fontAlgn="auto" latinLnBrk="0" hangingPunct="1">
-                <a:lnSpc>
-                  <a:spcPts val="3060"/>
-                </a:lnSpc>
-                <a:spcBef>
-                  <a:spcPts val="0"/>
-                </a:spcBef>
-                <a:spcAft>
-                  <a:spcPts val="0"/>
-                </a:spcAft>
-                <a:buClrTx/>
-                <a:buSzTx/>
-                <a:buFontTx/>
-                <a:buNone/>
-                <a:tabLst/>
-                <a:defRPr/>
-              </a:pPr>
-              <a:r>
-                <a:rPr kumimoji="0" lang="pt-PT" sz="1000" b="0" i="0" u="none" strike="noStrike" kern="1200" cap="none" spc="-150" normalizeH="0" baseline="0" noProof="0" dirty="0">
-                  <a:ln>
-                    <a:noFill/>
-                  </a:ln>
-                  <a:solidFill>
-                    <a:srgbClr val="342662"/>
-                  </a:solidFill>
-                  <a:effectLst/>
-                  <a:uLnTx/>
-                  <a:uFillTx/>
-                  <a:latin typeface="Aptos" panose="02110004020202020204"/>
-                  <a:ea typeface="+mn-ea"/>
-                  <a:cs typeface="+mn-cs"/>
-                </a:rPr>
-                <a:t>Mediação: 1 psicólogo coordenador + 1 referenciador (~5h/sem). Encaminhamentos manuais.</a:t>
-              </a:r>
-            </a:p>
-            <a:p>
-              <a:pPr marL="0" marR="0" lvl="0" indent="0" algn="l" defTabSz="914400" rtl="0" eaLnBrk="1" fontAlgn="auto" latinLnBrk="0" hangingPunct="1">
-                <a:lnSpc>
-                  <a:spcPts val="3060"/>
-                </a:lnSpc>
-                <a:spcBef>
-                  <a:spcPts val="0"/>
-                </a:spcBef>
-                <a:spcAft>
-                  <a:spcPts val="0"/>
-                </a:spcAft>
-                <a:buClrTx/>
-                <a:buSzTx/>
-                <a:buFontTx/>
-                <a:buNone/>
-                <a:tabLst/>
-                <a:defRPr/>
-              </a:pPr>
-              <a:r>
-                <a:rPr kumimoji="0" lang="pt-PT" sz="1000" b="0" i="0" u="none" strike="noStrike" kern="1200" cap="none" spc="-150" normalizeH="0" baseline="0" noProof="0" dirty="0">
-                  <a:ln>
-                    <a:noFill/>
-                  </a:ln>
-                  <a:solidFill>
-                    <a:srgbClr val="342662"/>
-                  </a:solidFill>
-                  <a:effectLst/>
-                  <a:uLnTx/>
-                  <a:uFillTx/>
-                  <a:latin typeface="Aptos" panose="02110004020202020204"/>
-                  <a:ea typeface="+mn-ea"/>
-                  <a:cs typeface="+mn-cs"/>
-                </a:rPr>
-                <a:t/>
-              </a:r>
-            </a:p>
-            <a:p>
-              <a:pPr marL="0" marR="0" lvl="0" indent="0" algn="l" defTabSz="914400" rtl="0" eaLnBrk="1" fontAlgn="auto" latinLnBrk="0" hangingPunct="1">
-                <a:lnSpc>
-                  <a:spcPts val="3060"/>
-                </a:lnSpc>
-                <a:spcBef>
-                  <a:spcPts val="0"/>
-                </a:spcBef>
-                <a:spcAft>
-                  <a:spcPts val="0"/>
-                </a:spcAft>
-                <a:buClrTx/>
-                <a:buSzTx/>
-                <a:buFontTx/>
-                <a:buNone/>
-                <a:tabLst/>
-                <a:defRPr/>
-              </a:pPr>
-              <a:r>
-                <a:rPr kumimoji="0" lang="pt-PT" sz="1000" b="0" i="0" u="none" strike="noStrike" kern="1200" cap="none" spc="-150" normalizeH="0" baseline="0" noProof="0" dirty="0">
-                  <a:ln>
-                    <a:noFill/>
-                  </a:ln>
-                  <a:solidFill>
-                    <a:srgbClr val="342662"/>
-                  </a:solidFill>
-                  <a:effectLst/>
-                  <a:uLnTx/>
-                  <a:uFillTx/>
-                  <a:latin typeface="Aptos" panose="02110004020202020204"/>
-                  <a:ea typeface="+mn-ea"/>
-                  <a:cs typeface="+mn-cs"/>
-                </a:rPr>
-                <a:t>Cronograma (10 sem):</a:t>
-              </a:r>
-            </a:p>
-            <a:p>
-              <a:pPr marL="0" marR="0" lvl="0" indent="0" algn="l" defTabSz="914400" rtl="0" eaLnBrk="1" fontAlgn="auto" latinLnBrk="0" hangingPunct="1">
-                <a:lnSpc>
-                  <a:spcPts val="3060"/>
-                </a:lnSpc>
-                <a:spcBef>
-                  <a:spcPts val="0"/>
-                </a:spcBef>
-                <a:spcAft>
-                  <a:spcPts val="0"/>
-                </a:spcAft>
-                <a:buClrTx/>
-                <a:buSzTx/>
-                <a:buFontTx/>
-                <a:buNone/>
-                <a:tabLst/>
-                <a:defRPr/>
-              </a:pPr>
-              <a:r>
-                <a:rPr kumimoji="0" lang="pt-PT" sz="1000" b="0" i="0" u="none" strike="noStrike" kern="1200" cap="none" spc="-150" normalizeH="0" baseline="0" noProof="0" dirty="0">
-                  <a:ln>
-                    <a:noFill/>
-                  </a:ln>
-                  <a:solidFill>
-                    <a:srgbClr val="342662"/>
-                  </a:solidFill>
-                  <a:effectLst/>
-                  <a:uLnTx/>
-                  <a:uFillTx/>
-                  <a:latin typeface="Aptos" panose="02110004020202020204"/>
-                  <a:ea typeface="+mn-ea"/>
-                  <a:cs typeface="+mn-cs"/>
-                </a:rPr>
-                <a:t>• Sem –2 a 0: Setup mindLAMP em Hetzner; CE-internal review; protocolo ético submetido à Comissão de Ética da universidade parceira; scripts de check-in adaptativo (regras, não ML)</a:t>
-              </a:r>
-            </a:p>
-            <a:p>
-              <a:pPr marL="0" marR="0" lvl="0" indent="0" algn="l" defTabSz="914400" rtl="0" eaLnBrk="1" fontAlgn="auto" latinLnBrk="0" hangingPunct="1">
-                <a:lnSpc>
-                  <a:spcPts val="3060"/>
-                </a:lnSpc>
-                <a:spcBef>
-                  <a:spcPts val="0"/>
-                </a:spcBef>
-                <a:spcAft>
-                  <a:spcPts val="0"/>
-                </a:spcAft>
-                <a:buClrTx/>
-                <a:buSzTx/>
-                <a:buFontTx/>
-                <a:buNone/>
-                <a:tabLst/>
-                <a:defRPr/>
-              </a:pPr>
-              <a:r>
-                <a:rPr kumimoji="0" lang="pt-PT" sz="1000" b="0" i="0" u="none" strike="noStrike" kern="1200" cap="none" spc="-150" normalizeH="0" baseline="0" noProof="0" dirty="0">
-                  <a:ln>
-                    <a:noFill/>
-                  </a:ln>
-                  <a:solidFill>
-                    <a:srgbClr val="342662"/>
-                  </a:solidFill>
-                  <a:effectLst/>
-                  <a:uLnTx/>
-                  <a:uFillTx/>
-                  <a:latin typeface="Aptos" panose="02110004020202020204"/>
-                  <a:ea typeface="+mn-ea"/>
-                  <a:cs typeface="+mn-cs"/>
-                </a:rPr>
-                <a:t/>
-              </a:r>
-            </a:p>
-            <a:p>
-              <a:pPr marL="0" marR="0" lvl="0" indent="0" algn="l" defTabSz="914400" rtl="0" eaLnBrk="1" fontAlgn="auto" latinLnBrk="0" hangingPunct="1">
-                <a:lnSpc>
-                  <a:spcPts val="3060"/>
-                </a:lnSpc>
-                <a:spcBef>
-                  <a:spcPts val="0"/>
-                </a:spcBef>
-                <a:spcAft>
-                  <a:spcPts val="0"/>
-                </a:spcAft>
-                <a:buClrTx/>
-                <a:buSzTx/>
-                <a:buFontTx/>
-                <a:buNone/>
-                <a:tabLst/>
-                <a:defRPr/>
-              </a:pPr>
-              <a:r>
-                <a:rPr kumimoji="0" lang="pt-PT" sz="1000" b="0" i="0" u="none" strike="noStrike" kern="1200" cap="none" spc="-150" normalizeH="0" baseline="0" noProof="0" dirty="0">
-                  <a:ln>
-                    <a:noFill/>
-                  </a:ln>
-                  <a:solidFill>
-                    <a:srgbClr val="342662"/>
-                  </a:solidFill>
-                  <a:effectLst/>
-                  <a:uLnTx/>
-                  <a:uFillTx/>
-                  <a:latin typeface="Aptos" panose="02110004020202020204"/>
-                  <a:ea typeface="+mn-ea"/>
-                  <a:cs typeface="+mn-cs"/>
-                </a:rPr>
-                <a:t>Endpoints: retenção 1.º→2.º contacto @4 sem (≥70%); compliance EMA ≥45%; Δ GAD-7/PHQ-9 ≥20% wk 8.</a:t>
+                <a:t>Piloto 12 semanas, mindLAMP Stack A, N=30–50 BCS 0–24 meses pós-tratamento ativo, recrutadas em consulta de senologia privada PT (CUF Oncologia primário; Lusíadas e Luz Saúde paralelos; IPO backup). Onboarding mediado pela equipa de senologia (modelo Limbic, EV-026). EMA PHQ-9/GAD-7 nas semanas 0/4/8/12 + sensing passivo + alertas priorizados ao dashboard de senologia (≤2/clínico/semana). Endpoint principal: delta PHQ-9 ≥3 / GAD-7 ≥2 e replicação AUC ≥0.72 em hold-out PT independente face a EV-043 (AUC 0.78, internal_only). Endpoint comercial: ≥2 LOIs hospitalares a ≥€200/clínico/mês [EV-047]. DPIA GDPR co-assinado com DPO hospitalar [EV-062]. Custo €5–10K externo ao orçamento da instituição-anfitriã [EV-046]; orçamento hospitalar €0 e zero novas contratações.</a:t>
               </a:r>
             </a:p>
           </p:txBody>
@@ -6825,7 +6465,7 @@
                 <a:defRPr/>
               </a:pPr>
               <a:r>
-                <a:rPr kumimoji="0" lang="pt-PT" sz="1400" b="0" i="0" u="none" strike="noStrike" kern="1200" cap="none" spc="-150" normalizeH="0" baseline="0" noProof="0" dirty="0">
+                <a:rPr kumimoji="0" lang="pt-PT" sz="900" b="0" i="0" u="none" strike="noStrike" kern="1200" cap="none" spc="-150" normalizeH="0" baseline="0" noProof="0" dirty="0">
                   <a:ln>
                     <a:noFill/>
                   </a:ln>
@@ -6839,7 +6479,7 @@
                   <a:ea typeface="+mn-ea"/>
                   <a:cs typeface="+mn-cs"/>
                 </a:rPr>
-                <a:t>€8.500–11.000</a:t>
+                <a:t>€5–10K, externo ao orçamento da instituição-anfitriã (host hospitalar €0, sem novas contratações). Anchor: EV-046 — desenvolvedor 30h €3–6K + infra mindLAMP Hetzner 3m €120 [EV-038] + 10 Fitbits reutilizáveis €2–3K + DPIA/contingência. Comparável: iNNOVSensing custou €120K para output estratégico equivalente [EV-048].</a:t>
               </a:r>
             </a:p>
           </p:txBody>
@@ -7073,7 +6713,7 @@
                 <a:defRPr/>
               </a:pPr>
               <a:r>
-                <a:rPr kumimoji="0" lang="pt-PT" sz="1000" b="0" i="0" u="none" strike="noStrike" kern="1200" cap="none" spc="-150" normalizeH="0" baseline="0" noProof="0" dirty="0">
+                <a:rPr kumimoji="0" lang="pt-PT" sz="850" b="0" i="0" u="none" strike="noStrike" kern="1200" cap="none" spc="-150" normalizeH="0" baseline="0" noProof="0" dirty="0">
                   <a:ln>
                     <a:noFill/>
                   </a:ln>
@@ -7087,7 +6727,7 @@
                   <a:ea typeface="+mn-ea"/>
                   <a:cs typeface="+mn-cs"/>
                 </a:rPr>
-                <a:t>Alinhado com banda EV-046 (€5–10K) acrescida de tempo clínico; ~10× mais barato que iNNOVSensing €120K (EV-048)</a:t>
+                <a:t>A equipa de senologia de pelo menos um hospital privado PT (CUF / Lusíadas / Luz Saúde) refere ≥50% das BCS elegíveis ao piloto e absorve ≤2 alertas/clínico/semana sem novas contratações nem aumento de orçamento hospitalar.</a:t>
               </a:r>
             </a:p>
           </p:txBody>
@@ -7305,7 +6945,7 @@
               <a:defRPr/>
             </a:pPr>
             <a:r>
-              <a:rPr kumimoji="0" lang="pt-PT" sz="900" b="0" i="0" u="none" strike="noStrike" kern="1200" cap="none" spc="-150" normalizeH="0" baseline="0" noProof="0" dirty="0">
+              <a:rPr kumimoji="0" lang="pt-PT" sz="850" b="0" i="0" u="none" strike="noStrike" kern="1200" cap="none" spc="-150" normalizeH="0" baseline="0" noProof="0" dirty="0">
                 <a:ln>
                   <a:noFill/>
                 </a:ln>
@@ -7319,7 +6959,7 @@
                 <a:ea typeface="+mn-ea"/>
                 <a:cs typeface="+mn-cs"/>
               </a:rPr>
-              <a:t>Referência institucional: To confirm — pelo menos um SASU (alvo: GAPsi FCUL ou SAS Coimbra) atribui 1 psicólogo coordenador + 1 psicólogo referenciador com ≥5h/sem disponíveis durante 10 semanas. Falsificável por carta de compromisso pré-semana –2.</a:t>
+              <a:t>A AUC 0.78 da deteção de depressão em BCS [EV-043, internal_only, N=126] replica em hold-out PT independente a ≥0.72, com EMA-compliance ≥50% e mix iOS/Android documentado [EV-039, EV-040].</a:t>
             </a:r>
           </a:p>
         </p:txBody>
@@ -7370,7 +7010,7 @@
               <a:defRPr/>
             </a:pPr>
             <a:r>
-              <a:rPr kumimoji="0" lang="pt-PT" sz="900" b="0" i="0" u="none" strike="noStrike" kern="1200" cap="none" spc="-150" normalizeH="0" baseline="0" noProof="0" dirty="0">
+              <a:rPr kumimoji="0" lang="pt-PT" sz="850" b="0" i="0" u="none" strike="noStrike" kern="1200" cap="none" spc="-150" normalizeH="0" baseline="0" noProof="0" dirty="0">
                 <a:ln>
                   <a:noFill/>
                 </a:ln>
@@ -7384,7 +7024,7 @@
                 <a:ea typeface="+mn-ea"/>
                 <a:cs typeface="+mn-cs"/>
               </a:rPr>
-              <a:t>Volume de fluxo: O canal digital do parceiro recebe ≥80 primeiros-contactos elegíveis em 2 semanas (necessário para 50% conversion → N=40). Falsificável por dados históricos do parceiro (to confirm: pedir baseline mensal de novos contactos 18–25).</a:t>
+              <a:t>Pelo menos 2 unidades de senologia privada PT assinam LOI ou piloto pago a ≥€200/clínico/mês até semana 12 [EV-047], com DPIA GDPR co-assinado pelo DPO hospitalar para neutralizar o risco precedente de €2.3M [EV-062].</a:t>
             </a:r>
           </a:p>
         </p:txBody>

</xml_diff>